<commit_message>
Actualiza los archivos de la entrega EDA
</commit_message>
<xml_diff>
--- a/E1 - EDA/Presentacion_E1_IA.pptx
+++ b/E1 - EDA/Presentacion_E1_IA.pptx
@@ -363,7 +363,7 @@
                   </a:defRPr>
                 </a:pPr>
                 <a:r>
-                  <a:rPr b="0" i="0" u="none" strike="noStrike">
+                  <a:rPr lang="es-CL" b="0" i="0" u="none" strike="noStrike">
                     <a:solidFill>
                       <a:srgbClr val="000000"/>
                     </a:solidFill>
@@ -663,7 +663,7 @@
                   </a:defRPr>
                 </a:pPr>
                 <a:r>
-                  <a:rPr b="0" i="0" u="none" strike="noStrike">
+                  <a:rPr lang="es-CL" b="0" i="0" u="none" strike="noStrike">
                     <a:solidFill>
                       <a:srgbClr val="000000"/>
                     </a:solidFill>
@@ -969,7 +969,7 @@
                   </a:defRPr>
                 </a:pPr>
                 <a:r>
-                  <a:rPr b="0" i="0" u="none" strike="noStrike">
+                  <a:rPr lang="es-CL" b="0" i="0" u="none" strike="noStrike">
                     <a:solidFill>
                       <a:srgbClr val="000000"/>
                     </a:solidFill>
@@ -1247,7 +1247,7 @@
                   </a:defRPr>
                 </a:pPr>
                 <a:r>
-                  <a:rPr b="0" i="0" u="none" strike="noStrike">
+                  <a:rPr lang="es-CL" b="0" i="0" u="none" strike="noStrike">
                     <a:solidFill>
                       <a:srgbClr val="000000"/>
                     </a:solidFill>
@@ -3830,8 +3830,8 @@
         </p:nvSpPr>
         <p:spPr>
           <a:xfrm>
-            <a:off x="9692640" y="-1645920"/>
-            <a:ext cx="4754880" cy="4754880"/>
+            <a:off x="10079420" y="-1645920"/>
+            <a:ext cx="4368099" cy="4315548"/>
           </a:xfrm>
           <a:prstGeom prst="ellipse">
             <a:avLst/>
@@ -3954,17 +3954,6 @@
             <a:pPr marL="0" indent="0">
               <a:buNone/>
             </a:pPr>
-            <a:r>
-              <a:rPr lang="en-US" sz="1300" b="1" kern="0" spc="250" dirty="0">
-                <a:solidFill>
-                  <a:srgbClr val="F2A541"/>
-                </a:solidFill>
-                <a:latin typeface="Calibri" pitchFamily="34" charset="0"/>
-                <a:ea typeface="Calibri" pitchFamily="34" charset="-122"/>
-                <a:cs typeface="Calibri" pitchFamily="34" charset="-120"/>
-              </a:rPr>
-              <a:t>EVALUACIÓN 1 · CALIDAD Y PREPARACIÓN DE DATOS</a:t>
-            </a:r>
             <a:endParaRPr lang="en-US" sz="1300" dirty="0"/>
           </a:p>
         </p:txBody>
@@ -3977,7 +3966,7 @@
         </p:nvSpPr>
         <p:spPr>
           <a:xfrm>
-            <a:off x="777240" y="1874520"/>
+            <a:off x="365760" y="1228528"/>
             <a:ext cx="10241280" cy="1737360"/>
           </a:xfrm>
           <a:prstGeom prst="rect">
@@ -4303,7 +4292,7 @@
         </p:nvSpPr>
         <p:spPr>
           <a:xfrm>
-            <a:off x="9006840" y="4526280"/>
+            <a:off x="8619008" y="4594860"/>
             <a:ext cx="2468880" cy="1691640"/>
           </a:xfrm>
           <a:prstGeom prst="roundRect">
@@ -4508,6 +4497,36 @@
           </a:p>
         </p:txBody>
       </p:sp>
+      <p:pic>
+        <p:nvPicPr>
+          <p:cNvPr id="21" name="Imagen 20">
+            <a:extLst>
+              <a:ext uri="{FF2B5EF4-FFF2-40B4-BE49-F238E27FC236}">
+                <a16:creationId xmlns:a16="http://schemas.microsoft.com/office/drawing/2014/main" id="{5B2373E2-BF7E-37FE-FEB6-0F8CD7021FC2}"/>
+              </a:ext>
+            </a:extLst>
+          </p:cNvPr>
+          <p:cNvPicPr>
+            <a:picLocks noChangeAspect="1"/>
+          </p:cNvPicPr>
+          <p:nvPr/>
+        </p:nvPicPr>
+        <p:blipFill>
+          <a:blip r:embed="rId3"/>
+          <a:stretch>
+            <a:fillRect/>
+          </a:stretch>
+        </p:blipFill>
+        <p:spPr>
+          <a:xfrm>
+            <a:off x="365760" y="327697"/>
+            <a:ext cx="2124701" cy="1408471"/>
+          </a:xfrm>
+          <a:prstGeom prst="rect">
+            <a:avLst/>
+          </a:prstGeom>
+        </p:spPr>
+      </p:pic>
     </p:spTree>
   </p:cSld>
   <p:clrMapOvr>
@@ -15276,7 +15295,7 @@
                 <a:ea typeface="Cambria" pitchFamily="34" charset="-122"/>
                 <a:cs typeface="Cambria" pitchFamily="34" charset="-120"/>
               </a:rPr>
-              <a:t>293→38</a:t>
+              <a:t>293</a:t>
             </a:r>
             <a:endParaRPr lang="en-US" sz="2600" dirty="0"/>
           </a:p>

</xml_diff>

<commit_message>
Actualiza los archivos en la entrega EDA
</commit_message>
<xml_diff>
--- a/E1 - EDA/Presentacion_E1_IA.pptx
+++ b/E1 - EDA/Presentacion_E1_IA.pptx
@@ -4239,7 +4239,7 @@
                 <a:ea typeface="Calibri" pitchFamily="34" charset="-122"/>
                 <a:cs typeface="Calibri" pitchFamily="34" charset="-120"/>
               </a:rPr>
-              <a:t>Benjamin Isla Pino  </a:t>
+              <a:t>Benjamín Isla Pino  </a:t>
             </a:r>
             <a:endParaRPr lang="en-US" sz="1250" dirty="0"/>
           </a:p>
@@ -4278,7 +4278,7 @@
                 <a:ea typeface="Calibri" pitchFamily="34" charset="-122"/>
                 <a:cs typeface="Calibri" pitchFamily="34" charset="-120"/>
               </a:rPr>
-              <a:t>Sebastian Isla Pino  </a:t>
+              <a:t>Sebastián Isla Pino  </a:t>
             </a:r>
             <a:endParaRPr lang="en-US" sz="1250" dirty="0"/>
           </a:p>
@@ -10632,7 +10632,7 @@
                 <a:ea typeface="Cambria" pitchFamily="34" charset="-122"/>
                 <a:cs typeface="Cambria" pitchFamily="34" charset="-120"/>
               </a:rPr>
-              <a:t>179</a:t>
+              <a:t>134</a:t>
             </a:r>
             <a:endParaRPr lang="en-US" sz="1250" dirty="0"/>
           </a:p>
@@ -15050,7 +15050,7 @@
                 <a:ea typeface="Cambria" pitchFamily="34" charset="-122"/>
                 <a:cs typeface="Cambria" pitchFamily="34" charset="-120"/>
               </a:rPr>
-              <a:t>179</a:t>
+              <a:t>134</a:t>
             </a:r>
             <a:endParaRPr lang="en-US" sz="2600" dirty="0"/>
           </a:p>

</xml_diff>